<commit_message>
chore: update coursework documents and remove obsolete build artifacts
</commit_message>
<xml_diff>
--- a/docs/SLIDES_REVISED.pptx
+++ b/docs/SLIDES_REVISED.pptx
@@ -184,9 +184,9 @@
 </file>
 
 <file path=ppt/notesMasters/theme/theme3.xml><?xml version="1.0" encoding="utf-8"?>
-<a:theme xmlns:a="http://schemas.openxmlformats.org/drawingml/2006/main" name="ChatGPT">
+<a:theme xmlns:a="http://schemas.openxmlformats.org/drawingml/2006/main" name="Flower Restoration">
   <a:themeElements>
-    <a:clrScheme name="ChatGPT">
+    <a:clrScheme name="Flower Restoration">
       <a:dk1>
         <a:srgbClr val="000000"/>
       </a:dk1>
@@ -236,7 +236,7 @@
         <a:cs typeface=""/>
       </a:minorFont>
     </a:fontScheme>
-    <a:fmtScheme name="ChatGPT">
+    <a:fmtScheme name="Flower Restoration">
       <a:fillStyleLst>
         <a:solidFill>
           <a:schemeClr val="phClr"/>
@@ -468,7 +468,7 @@
           <a:lstStyle xmlns:a="http://schemas.openxmlformats.org/drawingml/2006/main"/>
           <a:p xmlns:a="http://schemas.openxmlformats.org/drawingml/2006/main">
             <a:r>
-              <a:t>Phần trình bày đặt các thuật toán xử lý ảnh và chất lượng ảnh làm trọng tâm. MobileNetV2 chỉ là công cụ đo bổ sung. Không tự điền tên giảng viên, nhóm hoặc thành viên khi chưa được xác nhận.</a:t>
+              <a:t>Phần trình bày đặt các thuật toán xử lý ảnh và chất lượng ảnh làm trọng tâm. MobileNetV2 chỉ là công cụ đo bổ sung. Nhóm 05. Giảng viên: TS. Nguyễn Ngọc Giang. Thành viên: Nguyễn Tùng Dương (24100358), Trịnh Ngọc Nga (24100065), Trương Việt Thành (24106898).</a:t>
             </a:r>
           </a:p>
           <a:p xmlns:a="http://schemas.openxmlformats.org/drawingml/2006/main">
@@ -4859,9 +4859,9 @@
 </file>
 
 <file path=ppt/slideMasters/theme/theme2.xml><?xml version="1.0" encoding="utf-8"?>
-<a:theme xmlns:a="http://schemas.openxmlformats.org/drawingml/2006/main" name="ChatGPT">
+<a:theme xmlns:a="http://schemas.openxmlformats.org/drawingml/2006/main" name="Flower Restoration">
   <a:themeElements>
-    <a:clrScheme name="ChatGPT">
+    <a:clrScheme name="Flower Restoration">
       <a:dk1>
         <a:srgbClr val="000000"/>
       </a:dk1>
@@ -4911,7 +4911,7 @@
         <a:cs typeface=""/>
       </a:minorFont>
     </a:fontScheme>
-    <a:fmtScheme name="ChatGPT">
+    <a:fmtScheme name="Flower Restoration">
       <a:fillStyleLst>
         <a:solidFill>
           <a:schemeClr val="phClr"/>
@@ -5603,6 +5603,160 @@
                 </a:solidFill>
               </a:rPr>
               <a:t>5 dạng suy giảm  ·  49 điều kiện  ·  550 ảnh Test</a:t>
+            </a:r>
+          </a:p>
+        </p:txBody>
+      </p:sp>
+      <p:sp>
+        <p:nvSpPr>
+          <p:cNvPr id="6" name="Thông tin nhóm 05">
+            <a:extLst xmlns:a="http://schemas.openxmlformats.org/drawingml/2006/main">
+              <a:ext uri="{FF2B5EF4-FFF2-40B4-BE49-F238E27FC236}">
+                <a16:creationId xmlns:a16="http://schemas.microsoft.com/office/drawing/2014/main" id="{A56E9494-C6E6-40BA-BA34-A139343AEF21}"/>
+              </a:ext>
+            </a:extLst>
+          </p:cNvPr>
+          <p:cNvSpPr>
+            <a:spLocks xmlns:a="http://schemas.openxmlformats.org/drawingml/2006/main" noGrp="1"/>
+          </p:cNvSpPr>
+          <p:nvPr/>
+        </p:nvSpPr>
+        <p:spPr>
+          <a:xfrm xmlns:a="http://schemas.openxmlformats.org/drawingml/2006/main">
+            <a:off x="647700" y="6076950"/>
+            <a:ext cx="10477500" cy="628650"/>
+          </a:xfrm>
+          <a:prstGeom xmlns:a="http://schemas.openxmlformats.org/drawingml/2006/main" prst="rect">
+            <a:avLst/>
+          </a:prstGeom>
+          <a:noFill xmlns:a="http://schemas.openxmlformats.org/drawingml/2006/main"/>
+          <a:ln xmlns:a="http://schemas.openxmlformats.org/drawingml/2006/main" w="0">
+            <a:noFill/>
+          </a:ln>
+        </p:spPr>
+        <p:txBody>
+          <a:bodyPr xmlns:a="http://schemas.openxmlformats.org/drawingml/2006/main"/>
+          <a:lstStyle xmlns:a="http://schemas.openxmlformats.org/drawingml/2006/main">
+            <a:defPPr>
+              <a:defRPr sz="1350">
+                <a:solidFill>
+                  <a:srgbClr val="D9E8ED"/>
+                </a:solidFill>
+              </a:defRPr>
+            </a:defPPr>
+            <a:lvl1pPr>
+              <a:defRPr sz="1350">
+                <a:solidFill>
+                  <a:srgbClr val="D9E8ED"/>
+                </a:solidFill>
+              </a:defRPr>
+            </a:lvl1pPr>
+            <a:lvl2pPr>
+              <a:defRPr sz="1350">
+                <a:solidFill>
+                  <a:srgbClr val="D9E8ED"/>
+                </a:solidFill>
+              </a:defRPr>
+            </a:lvl2pPr>
+            <a:lvl3pPr>
+              <a:defRPr sz="1350">
+                <a:solidFill>
+                  <a:srgbClr val="D9E8ED"/>
+                </a:solidFill>
+              </a:defRPr>
+            </a:lvl3pPr>
+            <a:lvl4pPr>
+              <a:defRPr sz="1350">
+                <a:solidFill>
+                  <a:srgbClr val="D9E8ED"/>
+                </a:solidFill>
+              </a:defRPr>
+            </a:lvl4pPr>
+            <a:lvl5pPr>
+              <a:defRPr sz="1350">
+                <a:solidFill>
+                  <a:srgbClr val="D9E8ED"/>
+                </a:solidFill>
+              </a:defRPr>
+            </a:lvl5pPr>
+            <a:lvl6pPr>
+              <a:defRPr sz="1350">
+                <a:solidFill>
+                  <a:srgbClr val="D9E8ED"/>
+                </a:solidFill>
+              </a:defRPr>
+            </a:lvl6pPr>
+            <a:lvl7pPr>
+              <a:defRPr sz="1350">
+                <a:solidFill>
+                  <a:srgbClr val="D9E8ED"/>
+                </a:solidFill>
+              </a:defRPr>
+            </a:lvl7pPr>
+            <a:lvl8pPr>
+              <a:defRPr sz="1350">
+                <a:solidFill>
+                  <a:srgbClr val="D9E8ED"/>
+                </a:solidFill>
+              </a:defRPr>
+            </a:lvl8pPr>
+            <a:lvl9pPr>
+              <a:defRPr sz="1350">
+                <a:solidFill>
+                  <a:srgbClr val="D9E8ED"/>
+                </a:solidFill>
+              </a:defRPr>
+            </a:lvl9pPr>
+          </a:lstStyle>
+          <a:p xmlns:a="http://schemas.openxmlformats.org/drawingml/2006/main">
+            <a:pPr>
+              <a:defRPr sz="1350">
+                <a:solidFill>
+                  <a:srgbClr val="D9E8ED"/>
+                </a:solidFill>
+              </a:defRPr>
+            </a:pPr>
+            <a:r>
+              <a:rPr sz="1350">
+                <a:solidFill>
+                  <a:srgbClr val="D9E8ED"/>
+                </a:solidFill>
+              </a:rPr>
+              <a:t>Nhóm 05   Giảng viên: TS. Nguyễn Ngọc Giang</a:t>
+            </a:r>
+          </a:p>
+          <a:p xmlns:a="http://schemas.openxmlformats.org/drawingml/2006/main">
+            <a:pPr>
+              <a:defRPr sz="1350">
+                <a:solidFill>
+                  <a:srgbClr val="D9E8ED"/>
+                </a:solidFill>
+              </a:defRPr>
+            </a:pPr>
+            <a:r>
+              <a:rPr sz="1350">
+                <a:solidFill>
+                  <a:srgbClr val="D9E8ED"/>
+                </a:solidFill>
+              </a:rPr>
+              <a:t>Nguyễn Tùng Dương (24100358)   Trịnh Ngọc Nga (24100065)</a:t>
+            </a:r>
+          </a:p>
+          <a:p xmlns:a="http://schemas.openxmlformats.org/drawingml/2006/main">
+            <a:pPr>
+              <a:defRPr sz="1350">
+                <a:solidFill>
+                  <a:srgbClr val="D9E8ED"/>
+                </a:solidFill>
+              </a:defRPr>
+            </a:pPr>
+            <a:r>
+              <a:rPr sz="1350">
+                <a:solidFill>
+                  <a:srgbClr val="D9E8ED"/>
+                </a:solidFill>
+              </a:rPr>
+              <a:t>Trương Việt Thành (24106898)</a:t>
             </a:r>
           </a:p>
         </p:txBody>
@@ -20545,9 +20699,9 @@
 </file>
 
 <file path=ppt/theme/theme1.xml><?xml version="1.0" encoding="utf-8"?>
-<a:theme xmlns:a="http://schemas.openxmlformats.org/drawingml/2006/main" name="ChatGPT">
+<a:theme xmlns:a="http://schemas.openxmlformats.org/drawingml/2006/main" name="Flower Restoration">
   <a:themeElements>
-    <a:clrScheme name="ChatGPT">
+    <a:clrScheme name="Flower Restoration">
       <a:dk1>
         <a:srgbClr val="000000"/>
       </a:dk1>
@@ -20597,7 +20751,7 @@
         <a:cs typeface=""/>
       </a:minorFont>
     </a:fontScheme>
-    <a:fmtScheme name="ChatGPT">
+    <a:fmtScheme name="Flower Restoration">
       <a:fillStyleLst>
         <a:solidFill>
           <a:schemeClr val="phClr"/>

</xml_diff>